<commit_message>
feat: imposta titolo opzione 3 su slide Lezione 2 e sincronizza cartella
</commit_message>
<xml_diff>
--- a/lezione 2 - 28 ottobre 2026/Lezione2_Prompting_e_Pratica_ITS_MAKER.pptx
+++ b/lezione 2 - 28 ottobre 2026/Lezione2_Prompting_e_Pratica_ITS_MAKER.pptx
@@ -2070,7 +2070,7 @@
           <a:lstStyle/>
           <a:p>
             <a:r>
-              <a:t>Lezione 2 · Tecniche di Prompting d'Officina e Guida Operativa degli LLM</a:t>
+              <a:t>Lezione 2 · Tecniche di prompting: trasformare testo grezzo in dati strutturati</a:t>
             </a:r>
           </a:p>
         </p:txBody>
@@ -2356,7 +2356,7 @@
               </a:defRPr>
             </a:pPr>
             <a:r>
-              <a:t>IL CASO D'OFFICINA</a:t>
+              <a:t>IL CASO PRATICO DI PRODUZIONE</a:t>
             </a:r>
           </a:p>
           <a:p>
@@ -4358,7 +4358,7 @@
                         </a:defRPr>
                       </a:pPr>
                       <a:r>
-                        <a:t>Risposte affidabili basate solo sui manuali</a:t>
+                        <a:t>Risposte affidabili basate solo sui manuali tecnici</a:t>
                       </a:r>
                     </a:p>
                   </a:txBody>
@@ -4843,7 +4843,7 @@
               </a:defRPr>
             </a:pPr>
             <a:r>
-              <a:t>Un problema d'officina per volta</a:t>
+              <a:t>Un problema di processo per volta</a:t>
             </a:r>
           </a:p>
           <a:p>
@@ -5170,7 +5170,7 @@
               </a:defRPr>
             </a:pPr>
             <a:r>
-              <a:t>1. «Basta chiacchiere»: vincoli e tabelle  |  2. «Un esempio vale 1000 parole»: Few-Shot d'officina</a:t>
+              <a:t>1. «Basta chiacchiere»: vincoli e tabelle  |  2. «Un esempio vale 1000 parole»: Few-Shot per dati di processo</a:t>
             </a:r>
             <a:br/>
             <a:r>
@@ -5311,7 +5311,7 @@
               </a:defRPr>
             </a:pPr>
             <a:r>
-              <a:t>• È un rapporto didattico reale d'officina (DOC-FERMO nel vostro repository).</a:t>
+              <a:t>• È un rapporto didattico di manutenzione (DOC-FERMO nel vostro repository).</a:t>
             </a:r>
           </a:p>
           <a:p>

</xml_diff>

<commit_message>
refactor: rimuove ogni menzione di DOC-FERMO dal materiale allievi
</commit_message>
<xml_diff>
--- a/lezione 2 - 28 ottobre 2026/Lezione2_Prompting_e_Pratica_ITS_MAKER.pptx
+++ b/lezione 2 - 28 ottobre 2026/Lezione2_Prompting_e_Pratica_ITS_MAKER.pptx
@@ -5213,7 +5213,7 @@
           <a:lstStyle/>
           <a:p>
             <a:r>
-              <a:t>Il nostro pezzo grezzo: il rapporto di fermo (DOC-FERMO)</a:t>
+              <a:t>Il nostro pezzo grezzo: il rapporto di fermo macchina</a:t>
             </a:r>
           </a:p>
         </p:txBody>
@@ -5311,7 +5311,7 @@
               </a:defRPr>
             </a:pPr>
             <a:r>
-              <a:t>• È un rapporto didattico di manutenzione (DOC-FERMO nel vostro repository).</a:t>
+              <a:t>• È un rapporto didattico di manutenzione.</a:t>
             </a:r>
           </a:p>
           <a:p>
@@ -5450,7 +5450,7 @@
               </a:defRPr>
             </a:pPr>
             <a:r>
-              <a:t>Rapporto del 14 Ottobre (DOC-FERMO):</a:t>
+              <a:t>Rapporto di fermo macchina (14 Ottobre):</a:t>
             </a:r>
             <a:br/>
             <a:br/>

</xml_diff>